<commit_message>
Renderer: keep code boxes from wrapping; rebuild Day 9
Co-Authored-By: Claude Opus 5.5 <noreply@anthropic.com>
Claude-Session: https://claude.ai/code/session_019BWGGVhGSq3sUoebs4nKkF
</commit_message>
<xml_diff>
--- a/Day09-Nodejs-and-Express/Day09_Deck_Nodejs_and_Express.pptx
+++ b/Day09-Nodejs-and-Express/Day09_Deck_Nodejs_and_Express.pptx
@@ -6129,13 +6129,13 @@
           <a:noFill/>
         </p:spPr>
         <p:txBody>
-          <a:bodyPr wrap="square" lIns="0" rIns="0" tIns="0" bIns="0" anchor="t">
-            <a:spAutoFit/>
-          </a:bodyPr>
-          <a:lstStyle/>
-          <a:p>
-            <a:r>
-              <a:rPr sz="1400" b="0" i="0">
+          <a:bodyPr wrap="none" lIns="0" rIns="0" tIns="0" bIns="0" anchor="t">
+            <a:spAutoFit/>
+          </a:bodyPr>
+          <a:lstStyle/>
+          <a:p>
+            <a:r>
+              <a:rPr sz="1246" b="0" i="0">
                 <a:solidFill>
                   <a:srgbClr val="EAF7F5"/>
                 </a:solidFill>
@@ -6146,7 +6146,7 @@
           </a:p>
           <a:p>
             <a:r>
-              <a:rPr sz="1400" b="0" i="0">
+              <a:rPr sz="1246" b="0" i="0">
                 <a:solidFill>
                   <a:srgbClr val="EAF7F5"/>
                 </a:solidFill>
@@ -6157,7 +6157,7 @@
           </a:p>
           <a:p>
             <a:r>
-              <a:rPr sz="1400" b="0" i="0">
+              <a:rPr sz="1246" b="0" i="0">
                 <a:solidFill>
                   <a:srgbClr val="EAF7F5"/>
                 </a:solidFill>
@@ -6168,7 +6168,7 @@
           </a:p>
           <a:p>
             <a:r>
-              <a:rPr sz="1400" b="0" i="0">
+              <a:rPr sz="1246" b="0" i="0">
                 <a:solidFill>
                   <a:srgbClr val="EAF7F5"/>
                 </a:solidFill>
@@ -6179,7 +6179,7 @@
           </a:p>
           <a:p>
             <a:r>
-              <a:rPr sz="1400" b="0" i="0">
+              <a:rPr sz="1246" b="0" i="0">
                 <a:solidFill>
                   <a:srgbClr val="EAF7F5"/>
                 </a:solidFill>
@@ -6190,7 +6190,7 @@
           </a:p>
           <a:p>
             <a:r>
-              <a:rPr sz="1400" b="0" i="0">
+              <a:rPr sz="1246" b="0" i="0">
                 <a:solidFill>
                   <a:srgbClr val="EAF7F5"/>
                 </a:solidFill>
@@ -6201,7 +6201,7 @@
           </a:p>
           <a:p>
             <a:r>
-              <a:rPr sz="1400" b="0" i="0">
+              <a:rPr sz="1246" b="0" i="0">
                 <a:solidFill>
                   <a:srgbClr val="EAF7F5"/>
                 </a:solidFill>
@@ -6212,7 +6212,7 @@
           </a:p>
           <a:p>
             <a:r>
-              <a:rPr sz="1400" b="0" i="0">
+              <a:rPr sz="1246" b="0" i="0">
                 <a:solidFill>
                   <a:srgbClr val="EAF7F5"/>
                 </a:solidFill>
@@ -6223,7 +6223,7 @@
           </a:p>
           <a:p>
             <a:r>
-              <a:rPr sz="1400" b="0" i="0">
+              <a:rPr sz="1246" b="0" i="0">
                 <a:solidFill>
                   <a:srgbClr val="EAF7F5"/>
                 </a:solidFill>
@@ -6234,7 +6234,7 @@
           </a:p>
           <a:p>
             <a:r>
-              <a:rPr sz="1400" b="0" i="0">
+              <a:rPr sz="1246" b="0" i="0">
                 <a:solidFill>
                   <a:srgbClr val="EAF7F5"/>
                 </a:solidFill>
@@ -6245,7 +6245,7 @@
           </a:p>
           <a:p>
             <a:r>
-              <a:rPr sz="1400" b="0" i="0">
+              <a:rPr sz="1246" b="0" i="0">
                 <a:solidFill>
                   <a:srgbClr val="EAF7F5"/>
                 </a:solidFill>
@@ -7633,13 +7633,13 @@
           <a:noFill/>
         </p:spPr>
         <p:txBody>
-          <a:bodyPr wrap="square" lIns="0" rIns="0" tIns="0" bIns="0" anchor="t">
-            <a:spAutoFit/>
-          </a:bodyPr>
-          <a:lstStyle/>
-          <a:p>
-            <a:r>
-              <a:rPr sz="1400" b="0" i="0">
+          <a:bodyPr wrap="none" lIns="0" rIns="0" tIns="0" bIns="0" anchor="t">
+            <a:spAutoFit/>
+          </a:bodyPr>
+          <a:lstStyle/>
+          <a:p>
+            <a:r>
+              <a:rPr sz="1246" b="0" i="0">
                 <a:solidFill>
                   <a:srgbClr val="EAF7F5"/>
                 </a:solidFill>
@@ -7650,7 +7650,7 @@
           </a:p>
           <a:p>
             <a:r>
-              <a:rPr sz="1400" b="0" i="0">
+              <a:rPr sz="1246" b="0" i="0">
                 <a:solidFill>
                   <a:srgbClr val="EAF7F5"/>
                 </a:solidFill>
@@ -7661,7 +7661,7 @@
           </a:p>
           <a:p>
             <a:r>
-              <a:rPr sz="1400" b="0" i="0">
+              <a:rPr sz="1246" b="0" i="0">
                 <a:solidFill>
                   <a:srgbClr val="EAF7F5"/>
                 </a:solidFill>
@@ -7672,7 +7672,7 @@
           </a:p>
           <a:p>
             <a:r>
-              <a:rPr sz="1400" b="0" i="0">
+              <a:rPr sz="1246" b="0" i="0">
                 <a:solidFill>
                   <a:srgbClr val="EAF7F5"/>
                 </a:solidFill>
@@ -7683,7 +7683,7 @@
           </a:p>
           <a:p>
             <a:r>
-              <a:rPr sz="1400" b="0" i="0">
+              <a:rPr sz="1246" b="0" i="0">
                 <a:solidFill>
                   <a:srgbClr val="EAF7F5"/>
                 </a:solidFill>
@@ -7694,7 +7694,7 @@
           </a:p>
           <a:p>
             <a:r>
-              <a:rPr sz="1400" b="0" i="0">
+              <a:rPr sz="1246" b="0" i="0">
                 <a:solidFill>
                   <a:srgbClr val="EAF7F5"/>
                 </a:solidFill>
@@ -7705,7 +7705,7 @@
           </a:p>
           <a:p>
             <a:r>
-              <a:rPr sz="1400" b="0" i="0">
+              <a:rPr sz="1246" b="0" i="0">
                 <a:solidFill>
                   <a:srgbClr val="EAF7F5"/>
                 </a:solidFill>
@@ -7716,7 +7716,7 @@
           </a:p>
           <a:p>
             <a:r>
-              <a:rPr sz="1400" b="0" i="0">
+              <a:rPr sz="1246" b="0" i="0">
                 <a:solidFill>
                   <a:srgbClr val="EAF7F5"/>
                 </a:solidFill>
@@ -7727,7 +7727,7 @@
           </a:p>
           <a:p>
             <a:r>
-              <a:rPr sz="1400" b="0" i="0">
+              <a:rPr sz="1246" b="0" i="0">
                 <a:solidFill>
                   <a:srgbClr val="EAF7F5"/>
                 </a:solidFill>
@@ -7738,7 +7738,7 @@
           </a:p>
           <a:p>
             <a:r>
-              <a:rPr sz="1400" b="0" i="0">
+              <a:rPr sz="1246" b="0" i="0">
                 <a:solidFill>
                   <a:srgbClr val="EAF7F5"/>
                 </a:solidFill>
@@ -8522,13 +8522,13 @@
           <a:noFill/>
         </p:spPr>
         <p:txBody>
-          <a:bodyPr wrap="square" lIns="0" rIns="0" tIns="0" bIns="0" anchor="t">
-            <a:spAutoFit/>
-          </a:bodyPr>
-          <a:lstStyle/>
-          <a:p>
-            <a:r>
-              <a:rPr sz="1159" b="0" i="0">
+          <a:bodyPr wrap="none" lIns="0" rIns="0" tIns="0" bIns="0" anchor="t">
+            <a:spAutoFit/>
+          </a:bodyPr>
+          <a:lstStyle/>
+          <a:p>
+            <a:r>
+              <a:rPr sz="1020" b="0" i="0">
                 <a:solidFill>
                   <a:srgbClr val="EAF7F5"/>
                 </a:solidFill>
@@ -8539,7 +8539,7 @@
           </a:p>
           <a:p>
             <a:r>
-              <a:rPr sz="1159" b="0" i="0">
+              <a:rPr sz="1020" b="0" i="0">
                 <a:solidFill>
                   <a:srgbClr val="EAF7F5"/>
                 </a:solidFill>
@@ -8550,7 +8550,7 @@
           </a:p>
           <a:p>
             <a:r>
-              <a:rPr sz="1159" b="0" i="0">
+              <a:rPr sz="1020" b="0" i="0">
                 <a:solidFill>
                   <a:srgbClr val="EAF7F5"/>
                 </a:solidFill>
@@ -8561,7 +8561,7 @@
           </a:p>
           <a:p>
             <a:r>
-              <a:rPr sz="1159" b="0" i="0">
+              <a:rPr sz="1020" b="0" i="0">
                 <a:solidFill>
                   <a:srgbClr val="EAF7F5"/>
                 </a:solidFill>
@@ -8572,7 +8572,7 @@
           </a:p>
           <a:p>
             <a:r>
-              <a:rPr sz="1159" b="0" i="0">
+              <a:rPr sz="1020" b="0" i="0">
                 <a:solidFill>
                   <a:srgbClr val="EAF7F5"/>
                 </a:solidFill>
@@ -8583,7 +8583,7 @@
           </a:p>
           <a:p>
             <a:r>
-              <a:rPr sz="1159" b="0" i="0">
+              <a:rPr sz="1020" b="0" i="0">
                 <a:solidFill>
                   <a:srgbClr val="EAF7F5"/>
                 </a:solidFill>
@@ -8594,7 +8594,7 @@
           </a:p>
           <a:p>
             <a:r>
-              <a:rPr sz="1159" b="0" i="0">
+              <a:rPr sz="1020" b="0" i="0">
                 <a:solidFill>
                   <a:srgbClr val="EAF7F5"/>
                 </a:solidFill>
@@ -8605,7 +8605,7 @@
           </a:p>
           <a:p>
             <a:r>
-              <a:rPr sz="1159" b="0" i="0">
+              <a:rPr sz="1020" b="0" i="0">
                 <a:solidFill>
                   <a:srgbClr val="EAF7F5"/>
                 </a:solidFill>
@@ -8616,7 +8616,7 @@
           </a:p>
           <a:p>
             <a:r>
-              <a:rPr sz="1159" b="0" i="0">
+              <a:rPr sz="1020" b="0" i="0">
                 <a:solidFill>
                   <a:srgbClr val="EAF7F5"/>
                 </a:solidFill>
@@ -8627,7 +8627,7 @@
           </a:p>
           <a:p>
             <a:r>
-              <a:rPr sz="1159" b="0" i="0">
+              <a:rPr sz="1020" b="0" i="0">
                 <a:solidFill>
                   <a:srgbClr val="EAF7F5"/>
                 </a:solidFill>
@@ -8638,7 +8638,7 @@
           </a:p>
           <a:p>
             <a:r>
-              <a:rPr sz="1159" b="0" i="0">
+              <a:rPr sz="1020" b="0" i="0">
                 <a:solidFill>
                   <a:srgbClr val="EAF7F5"/>
                 </a:solidFill>
@@ -10236,13 +10236,13 @@
           <a:noFill/>
         </p:spPr>
         <p:txBody>
-          <a:bodyPr wrap="square" lIns="0" rIns="0" tIns="0" bIns="0" anchor="t">
-            <a:spAutoFit/>
-          </a:bodyPr>
-          <a:lstStyle/>
-          <a:p>
-            <a:r>
-              <a:rPr sz="1214" b="0" i="0">
+          <a:bodyPr wrap="none" lIns="0" rIns="0" tIns="0" bIns="0" anchor="t">
+            <a:spAutoFit/>
+          </a:bodyPr>
+          <a:lstStyle/>
+          <a:p>
+            <a:r>
+              <a:rPr sz="1068" b="0" i="0">
                 <a:solidFill>
                   <a:srgbClr val="EAF7F5"/>
                 </a:solidFill>
@@ -10253,7 +10253,7 @@
           </a:p>
           <a:p>
             <a:r>
-              <a:rPr sz="1214" b="0" i="0">
+              <a:rPr sz="1068" b="0" i="0">
                 <a:solidFill>
                   <a:srgbClr val="EAF7F5"/>
                 </a:solidFill>
@@ -10264,7 +10264,7 @@
           </a:p>
           <a:p>
             <a:r>
-              <a:rPr sz="1214" b="0" i="0">
+              <a:rPr sz="1068" b="0" i="0">
                 <a:solidFill>
                   <a:srgbClr val="EAF7F5"/>
                 </a:solidFill>
@@ -10275,7 +10275,7 @@
           </a:p>
           <a:p>
             <a:r>
-              <a:rPr sz="1214" b="0" i="0">
+              <a:rPr sz="1068" b="0" i="0">
                 <a:solidFill>
                   <a:srgbClr val="EAF7F5"/>
                 </a:solidFill>
@@ -10286,7 +10286,7 @@
           </a:p>
           <a:p>
             <a:r>
-              <a:rPr sz="1214" b="0" i="0">
+              <a:rPr sz="1068" b="0" i="0">
                 <a:solidFill>
                   <a:srgbClr val="EAF7F5"/>
                 </a:solidFill>
@@ -10297,7 +10297,7 @@
           </a:p>
           <a:p>
             <a:r>
-              <a:rPr sz="1214" b="0" i="0">
+              <a:rPr sz="1068" b="0" i="0">
                 <a:solidFill>
                   <a:srgbClr val="EAF7F5"/>
                 </a:solidFill>
@@ -10308,7 +10308,7 @@
           </a:p>
           <a:p>
             <a:r>
-              <a:rPr sz="1214" b="0" i="0">
+              <a:rPr sz="1068" b="0" i="0">
                 <a:solidFill>
                   <a:srgbClr val="EAF7F5"/>
                 </a:solidFill>
@@ -10319,7 +10319,7 @@
           </a:p>
           <a:p>
             <a:r>
-              <a:rPr sz="1214" b="0" i="0">
+              <a:rPr sz="1068" b="0" i="0">
                 <a:solidFill>
                   <a:srgbClr val="EAF7F5"/>
                 </a:solidFill>
@@ -10330,7 +10330,7 @@
           </a:p>
           <a:p>
             <a:r>
-              <a:rPr sz="1214" b="0" i="0">
+              <a:rPr sz="1068" b="0" i="0">
                 <a:solidFill>
                   <a:srgbClr val="EAF7F5"/>
                 </a:solidFill>
@@ -10341,7 +10341,7 @@
           </a:p>
           <a:p>
             <a:r>
-              <a:rPr sz="1214" b="0" i="0">
+              <a:rPr sz="1068" b="0" i="0">
                 <a:solidFill>
                   <a:srgbClr val="EAF7F5"/>
                 </a:solidFill>
@@ -10352,7 +10352,7 @@
           </a:p>
           <a:p>
             <a:r>
-              <a:rPr sz="1214" b="0" i="0">
+              <a:rPr sz="1068" b="0" i="0">
                 <a:solidFill>
                   <a:srgbClr val="EAF7F5"/>
                 </a:solidFill>
@@ -10363,7 +10363,7 @@
           </a:p>
           <a:p>
             <a:r>
-              <a:rPr sz="1214" b="0" i="0">
+              <a:rPr sz="1068" b="0" i="0">
                 <a:solidFill>
                   <a:srgbClr val="EAF7F5"/>
                 </a:solidFill>
@@ -12542,13 +12542,13 @@
           <a:noFill/>
         </p:spPr>
         <p:txBody>
-          <a:bodyPr wrap="square" lIns="0" rIns="0" tIns="0" bIns="0" anchor="t">
-            <a:spAutoFit/>
-          </a:bodyPr>
-          <a:lstStyle/>
-          <a:p>
-            <a:r>
-              <a:rPr sz="1400" b="0" i="0">
+          <a:bodyPr wrap="none" lIns="0" rIns="0" tIns="0" bIns="0" anchor="t">
+            <a:spAutoFit/>
+          </a:bodyPr>
+          <a:lstStyle/>
+          <a:p>
+            <a:r>
+              <a:rPr sz="1320" b="0" i="0">
                 <a:solidFill>
                   <a:srgbClr val="EAF7F5"/>
                 </a:solidFill>
@@ -12559,7 +12559,7 @@
           </a:p>
           <a:p>
             <a:r>
-              <a:rPr sz="1400" b="0" i="0">
+              <a:rPr sz="1320" b="0" i="0">
                 <a:solidFill>
                   <a:srgbClr val="EAF7F5"/>
                 </a:solidFill>
@@ -12570,7 +12570,7 @@
           </a:p>
           <a:p>
             <a:r>
-              <a:rPr sz="1400" b="0" i="0">
+              <a:rPr sz="1320" b="0" i="0">
                 <a:solidFill>
                   <a:srgbClr val="EAF7F5"/>
                 </a:solidFill>
@@ -12581,7 +12581,7 @@
           </a:p>
           <a:p>
             <a:r>
-              <a:rPr sz="1400" b="0" i="0">
+              <a:rPr sz="1320" b="0" i="0">
                 <a:solidFill>
                   <a:srgbClr val="EAF7F5"/>
                 </a:solidFill>
@@ -12592,7 +12592,7 @@
           </a:p>
           <a:p>
             <a:r>
-              <a:rPr sz="1400" b="0" i="0">
+              <a:rPr sz="1320" b="0" i="0">
                 <a:solidFill>
                   <a:srgbClr val="EAF7F5"/>
                 </a:solidFill>
@@ -12603,7 +12603,7 @@
           </a:p>
           <a:p>
             <a:r>
-              <a:rPr sz="1400" b="0" i="0">
+              <a:rPr sz="1320" b="0" i="0">
                 <a:solidFill>
                   <a:srgbClr val="EAF7F5"/>
                 </a:solidFill>
@@ -12614,7 +12614,7 @@
           </a:p>
           <a:p>
             <a:r>
-              <a:rPr sz="1400" b="0" i="0">
+              <a:rPr sz="1320" b="0" i="0">
                 <a:solidFill>
                   <a:srgbClr val="EAF7F5"/>
                 </a:solidFill>
@@ -12625,7 +12625,7 @@
           </a:p>
           <a:p>
             <a:r>
-              <a:rPr sz="1400" b="0" i="0">
+              <a:rPr sz="1320" b="0" i="0">
                 <a:solidFill>
                   <a:srgbClr val="EAF7F5"/>
                 </a:solidFill>
@@ -12636,7 +12636,7 @@
           </a:p>
           <a:p>
             <a:r>
-              <a:rPr sz="1400" b="0" i="0">
+              <a:rPr sz="1320" b="0" i="0">
                 <a:solidFill>
                   <a:srgbClr val="EAF7F5"/>
                 </a:solidFill>
@@ -12924,13 +12924,13 @@
           <a:noFill/>
         </p:spPr>
         <p:txBody>
-          <a:bodyPr wrap="square" lIns="0" rIns="0" tIns="0" bIns="0" anchor="t">
-            <a:spAutoFit/>
-          </a:bodyPr>
-          <a:lstStyle/>
-          <a:p>
-            <a:r>
-              <a:rPr sz="1133" b="0" i="0">
+          <a:bodyPr wrap="none" lIns="0" rIns="0" tIns="0" bIns="0" anchor="t">
+            <a:spAutoFit/>
+          </a:bodyPr>
+          <a:lstStyle/>
+          <a:p>
+            <a:r>
+              <a:rPr sz="997" b="0" i="0">
                 <a:solidFill>
                   <a:srgbClr val="EAF7F5"/>
                 </a:solidFill>
@@ -12941,7 +12941,7 @@
           </a:p>
           <a:p>
             <a:r>
-              <a:rPr sz="1133" b="0" i="0">
+              <a:rPr sz="997" b="0" i="0">
                 <a:solidFill>
                   <a:srgbClr val="EAF7F5"/>
                 </a:solidFill>
@@ -12952,7 +12952,7 @@
           </a:p>
           <a:p>
             <a:r>
-              <a:rPr sz="1133" b="0" i="0">
+              <a:rPr sz="997" b="0" i="0">
                 <a:solidFill>
                   <a:srgbClr val="EAF7F5"/>
                 </a:solidFill>
@@ -12963,7 +12963,7 @@
           </a:p>
           <a:p>
             <a:r>
-              <a:rPr sz="1133" b="0" i="0">
+              <a:rPr sz="997" b="0" i="0">
                 <a:solidFill>
                   <a:srgbClr val="EAF7F5"/>
                 </a:solidFill>
@@ -12974,7 +12974,7 @@
           </a:p>
           <a:p>
             <a:r>
-              <a:rPr sz="1133" b="0" i="0">
+              <a:rPr sz="997" b="0" i="0">
                 <a:solidFill>
                   <a:srgbClr val="EAF7F5"/>
                 </a:solidFill>
@@ -12985,7 +12985,7 @@
           </a:p>
           <a:p>
             <a:r>
-              <a:rPr sz="1133" b="0" i="0">
+              <a:rPr sz="997" b="0" i="0">
                 <a:solidFill>
                   <a:srgbClr val="EAF7F5"/>
                 </a:solidFill>
@@ -12996,7 +12996,7 @@
           </a:p>
           <a:p>
             <a:r>
-              <a:rPr sz="1133" b="0" i="0">
+              <a:rPr sz="997" b="0" i="0">
                 <a:solidFill>
                   <a:srgbClr val="EAF7F5"/>
                 </a:solidFill>
@@ -13007,7 +13007,7 @@
           </a:p>
           <a:p>
             <a:r>
-              <a:rPr sz="1133" b="0" i="0">
+              <a:rPr sz="997" b="0" i="0">
                 <a:solidFill>
                   <a:srgbClr val="EAF7F5"/>
                 </a:solidFill>
@@ -13018,7 +13018,7 @@
           </a:p>
           <a:p>
             <a:r>
-              <a:rPr sz="1133" b="0" i="0">
+              <a:rPr sz="997" b="0" i="0">
                 <a:solidFill>
                   <a:srgbClr val="EAF7F5"/>
                 </a:solidFill>
@@ -13029,7 +13029,7 @@
           </a:p>
           <a:p>
             <a:r>
-              <a:rPr sz="1133" b="0" i="0">
+              <a:rPr sz="997" b="0" i="0">
                 <a:solidFill>
                   <a:srgbClr val="EAF7F5"/>
                 </a:solidFill>
@@ -13040,7 +13040,7 @@
           </a:p>
           <a:p>
             <a:r>
-              <a:rPr sz="1133" b="0" i="0">
+              <a:rPr sz="997" b="0" i="0">
                 <a:solidFill>
                   <a:srgbClr val="EAF7F5"/>
                 </a:solidFill>
@@ -13051,7 +13051,7 @@
           </a:p>
           <a:p>
             <a:r>
-              <a:rPr sz="1133" b="0" i="0">
+              <a:rPr sz="997" b="0" i="0">
                 <a:solidFill>
                   <a:srgbClr val="EAF7F5"/>
                 </a:solidFill>
@@ -13062,7 +13062,7 @@
           </a:p>
           <a:p>
             <a:r>
-              <a:rPr sz="1133" b="0" i="0">
+              <a:rPr sz="997" b="0" i="0">
                 <a:solidFill>
                   <a:srgbClr val="EAF7F5"/>
                 </a:solidFill>
@@ -19500,13 +19500,13 @@
           <a:noFill/>
         </p:spPr>
         <p:txBody>
-          <a:bodyPr wrap="square" lIns="0" rIns="0" tIns="0" bIns="0" anchor="t">
-            <a:spAutoFit/>
-          </a:bodyPr>
-          <a:lstStyle/>
-          <a:p>
-            <a:r>
-              <a:rPr sz="1400" b="0" i="0">
+          <a:bodyPr wrap="none" lIns="0" rIns="0" tIns="0" bIns="0" anchor="t">
+            <a:spAutoFit/>
+          </a:bodyPr>
+          <a:lstStyle/>
+          <a:p>
+            <a:r>
+              <a:rPr sz="1282" b="0" i="0">
                 <a:solidFill>
                   <a:srgbClr val="EAF7F5"/>
                 </a:solidFill>
@@ -19517,7 +19517,7 @@
           </a:p>
           <a:p>
             <a:r>
-              <a:rPr sz="1400" b="0" i="0">
+              <a:rPr sz="1282" b="0" i="0">
                 <a:solidFill>
                   <a:srgbClr val="EAF7F5"/>
                 </a:solidFill>
@@ -19528,7 +19528,7 @@
           </a:p>
           <a:p>
             <a:r>
-              <a:rPr sz="1400" b="0" i="0">
+              <a:rPr sz="1282" b="0" i="0">
                 <a:solidFill>
                   <a:srgbClr val="EAF7F5"/>
                 </a:solidFill>
@@ -19539,7 +19539,7 @@
           </a:p>
           <a:p>
             <a:r>
-              <a:rPr sz="1400" b="0" i="0">
+              <a:rPr sz="1282" b="0" i="0">
                 <a:solidFill>
                   <a:srgbClr val="EAF7F5"/>
                 </a:solidFill>
@@ -19550,7 +19550,7 @@
           </a:p>
           <a:p>
             <a:r>
-              <a:rPr sz="1400" b="0" i="0">
+              <a:rPr sz="1282" b="0" i="0">
                 <a:solidFill>
                   <a:srgbClr val="EAF7F5"/>
                 </a:solidFill>
@@ -19561,7 +19561,7 @@
           </a:p>
           <a:p>
             <a:r>
-              <a:rPr sz="1400" b="0" i="0">
+              <a:rPr sz="1282" b="0" i="0">
                 <a:solidFill>
                   <a:srgbClr val="EAF7F5"/>
                 </a:solidFill>
@@ -19572,7 +19572,7 @@
           </a:p>
           <a:p>
             <a:r>
-              <a:rPr sz="1400" b="0" i="0">
+              <a:rPr sz="1282" b="0" i="0">
                 <a:solidFill>
                   <a:srgbClr val="EAF7F5"/>
                 </a:solidFill>
@@ -19583,7 +19583,7 @@
           </a:p>
           <a:p>
             <a:r>
-              <a:rPr sz="1400" b="0" i="0">
+              <a:rPr sz="1282" b="0" i="0">
                 <a:solidFill>
                   <a:srgbClr val="EAF7F5"/>
                 </a:solidFill>
@@ -19594,7 +19594,7 @@
           </a:p>
           <a:p>
             <a:r>
-              <a:rPr sz="1400" b="0" i="0">
+              <a:rPr sz="1282" b="0" i="0">
                 <a:solidFill>
                   <a:srgbClr val="EAF7F5"/>
                 </a:solidFill>
@@ -19605,7 +19605,7 @@
           </a:p>
           <a:p>
             <a:r>
-              <a:rPr sz="1400" b="0" i="0">
+              <a:rPr sz="1282" b="0" i="0">
                 <a:solidFill>
                   <a:srgbClr val="EAF7F5"/>
                 </a:solidFill>
@@ -19616,7 +19616,7 @@
           </a:p>
           <a:p>
             <a:r>
-              <a:rPr sz="1400" b="0" i="0">
+              <a:rPr sz="1282" b="0" i="0">
                 <a:solidFill>
                   <a:srgbClr val="EAF7F5"/>
                 </a:solidFill>
@@ -19627,7 +19627,7 @@
           </a:p>
           <a:p>
             <a:r>
-              <a:rPr sz="1400" b="0" i="0">
+              <a:rPr sz="1282" b="0" i="0">
                 <a:solidFill>
                   <a:srgbClr val="EAF7F5"/>
                 </a:solidFill>
@@ -19638,7 +19638,7 @@
           </a:p>
           <a:p>
             <a:r>
-              <a:rPr sz="1400" b="0" i="0">
+              <a:rPr sz="1282" b="0" i="0">
                 <a:solidFill>
                   <a:srgbClr val="EAF7F5"/>
                 </a:solidFill>
@@ -20403,13 +20403,13 @@
           <a:noFill/>
         </p:spPr>
         <p:txBody>
-          <a:bodyPr wrap="square" lIns="0" rIns="0" tIns="0" bIns="0" anchor="t">
-            <a:spAutoFit/>
-          </a:bodyPr>
-          <a:lstStyle/>
-          <a:p>
-            <a:r>
-              <a:rPr sz="1378" b="0" i="0">
+          <a:bodyPr wrap="none" lIns="0" rIns="0" tIns="0" bIns="0" anchor="t">
+            <a:spAutoFit/>
+          </a:bodyPr>
+          <a:lstStyle/>
+          <a:p>
+            <a:r>
+              <a:rPr sz="1212" b="0" i="0">
                 <a:solidFill>
                   <a:srgbClr val="EAF7F5"/>
                 </a:solidFill>
@@ -20420,7 +20420,7 @@
           </a:p>
           <a:p>
             <a:r>
-              <a:rPr sz="1378" b="0" i="0">
+              <a:rPr sz="1212" b="0" i="0">
                 <a:solidFill>
                   <a:srgbClr val="EAF7F5"/>
                 </a:solidFill>
@@ -20431,7 +20431,7 @@
           </a:p>
           <a:p>
             <a:r>
-              <a:rPr sz="1378" b="0" i="0">
+              <a:rPr sz="1212" b="0" i="0">
                 <a:solidFill>
                   <a:srgbClr val="EAF7F5"/>
                 </a:solidFill>
@@ -20442,7 +20442,7 @@
           </a:p>
           <a:p>
             <a:r>
-              <a:rPr sz="1378" b="0" i="0">
+              <a:rPr sz="1212" b="0" i="0">
                 <a:solidFill>
                   <a:srgbClr val="EAF7F5"/>
                 </a:solidFill>
@@ -20453,7 +20453,7 @@
           </a:p>
           <a:p>
             <a:r>
-              <a:rPr sz="1378" b="0" i="0">
+              <a:rPr sz="1212" b="0" i="0">
                 <a:solidFill>
                   <a:srgbClr val="EAF7F5"/>
                 </a:solidFill>
@@ -20464,7 +20464,7 @@
           </a:p>
           <a:p>
             <a:r>
-              <a:rPr sz="1378" b="0" i="0">
+              <a:rPr sz="1212" b="0" i="0">
                 <a:solidFill>
                   <a:srgbClr val="EAF7F5"/>
                 </a:solidFill>
@@ -20475,7 +20475,7 @@
           </a:p>
           <a:p>
             <a:r>
-              <a:rPr sz="1378" b="0" i="0">
+              <a:rPr sz="1212" b="0" i="0">
                 <a:solidFill>
                   <a:srgbClr val="EAF7F5"/>
                 </a:solidFill>
@@ -20486,7 +20486,7 @@
           </a:p>
           <a:p>
             <a:r>
-              <a:rPr sz="1378" b="0" i="0">
+              <a:rPr sz="1212" b="0" i="0">
                 <a:solidFill>
                   <a:srgbClr val="EAF7F5"/>
                 </a:solidFill>
@@ -20497,7 +20497,7 @@
           </a:p>
           <a:p>
             <a:r>
-              <a:rPr sz="1378" b="0" i="0">
+              <a:rPr sz="1212" b="0" i="0">
                 <a:solidFill>
                   <a:srgbClr val="EAF7F5"/>
                 </a:solidFill>
@@ -20508,7 +20508,7 @@
           </a:p>
           <a:p>
             <a:r>
-              <a:rPr sz="1378" b="0" i="0">
+              <a:rPr sz="1212" b="0" i="0">
                 <a:solidFill>
                   <a:srgbClr val="EAF7F5"/>
                 </a:solidFill>
@@ -20519,7 +20519,7 @@
           </a:p>
           <a:p>
             <a:r>
-              <a:rPr sz="1378" b="0" i="0">
+              <a:rPr sz="1212" b="0" i="0">
                 <a:solidFill>
                   <a:srgbClr val="EAF7F5"/>
                 </a:solidFill>
@@ -20530,7 +20530,7 @@
           </a:p>
           <a:p>
             <a:r>
-              <a:rPr sz="1378" b="0" i="0">
+              <a:rPr sz="1212" b="0" i="0">
                 <a:solidFill>
                   <a:srgbClr val="EAF7F5"/>
                 </a:solidFill>

</xml_diff>